<commit_message>
Merge Summary + Future slides; condense refinement areas and fold in LLM next-step
Rebuilt deck cleanly from original to avoid duplicate slide parts.

Co-Authored-By: Claude Opus 4.8 <noreply@anthropic.com>
Claude-Session: https://claude.ai/code/session_01QsqkGEZQkSxfsNCNnWC7Vk
</commit_message>
<xml_diff>
--- a/DEMO_PPT.pptx
+++ b/DEMO_PPT.pptx
@@ -15,7 +15,6 @@
     <p:sldId id="261" r:id="rId6"/>
     <p:sldId id="265" r:id="rId8"/>
     <p:sldId id="266" r:id="rId9"/>
-    <p:sldId id="267" r:id="rId10"/>
   </p:sldIdLst>
   <p:sldSz cx="12192000" cy="6858000"/>
   <p:notesSz cx="6858000" cy="12192000"/>
@@ -1357,93 +1356,6 @@
 </p:notes>
 </file>
 
-<file path=ppt/notesSlides/notesSlide6.xml><?xml version="1.0" encoding="utf-8"?>
-<p:notes xmlns:a="http://schemas.openxmlformats.org/drawingml/2006/main" xmlns:r="http://schemas.openxmlformats.org/officeDocument/2006/relationships" xmlns:p="http://schemas.openxmlformats.org/presentationml/2006/main">
-  <p:cSld>
-    <p:spTree>
-      <p:nvGrpSpPr>
-        <p:cNvPr id="1" name=""/>
-        <p:cNvGrpSpPr/>
-        <p:nvPr/>
-      </p:nvGrpSpPr>
-      <p:grpSpPr>
-        <a:xfrm>
-          <a:off x="0" y="0"/>
-          <a:ext cx="0" cy="0"/>
-          <a:chOff x="0" y="0"/>
-          <a:chExt cx="0" cy="0"/>
-        </a:xfrm>
-      </p:grpSpPr>
-      <p:sp>
-        <p:nvSpPr>
-          <p:cNvPr id="2" name="Slide Image Placeholder 1"/>
-          <p:cNvSpPr>
-            <a:spLocks noGrp="1" noRot="1" noChangeAspect="1"/>
-          </p:cNvSpPr>
-          <p:nvPr>
-            <p:ph type="sldImg"/>
-          </p:nvPr>
-        </p:nvSpPr>
-        <p:spPr/>
-      </p:sp>
-      <p:sp>
-        <p:nvSpPr>
-          <p:cNvPr id="3" name="Notes Placeholder 2"/>
-          <p:cNvSpPr>
-            <a:spLocks noGrp="1"/>
-          </p:cNvSpPr>
-          <p:nvPr>
-            <p:ph type="body" idx="1"/>
-          </p:nvPr>
-        </p:nvSpPr>
-        <p:spPr/>
-        <p:txBody>
-          <a:bodyPr/>
-          <a:lstStyle/>
-          <a:p>
-            <a:r>
-              <a:rPr lang="en-US" dirty="0"/>
-              <a:t>This is the engine. Fields flow left to right and escalate only if unresolved. Tier 0 — form-scoped match: read the form code from the header, scope to that form, match the label; confidence 0.98 because it's exact and context-verified, covering ~85%. Tier 1 — NOT SUBMITTED: system/helper fields such as 'Field created for RSG to calculate height' are correctly excluded rather than force-mapped; confidence 0.99. Tier 2 — cross-module fuzzy match: searches all modules for the in-form leftovers, accepts only above threshold, otherwise leaves it unannotated so the programmer knows exactly what to check; 0.85–0.95. Net automation ~90%, ~10% to manual review — as the metric cards in the diagram show.</a:t>
-            </a:r>
-          </a:p>
-        </p:txBody>
-      </p:sp>
-      <p:sp>
-        <p:nvSpPr>
-          <p:cNvPr id="4" name="Slide Number Placeholder 3"/>
-          <p:cNvSpPr>
-            <a:spLocks noGrp="1"/>
-          </p:cNvSpPr>
-          <p:nvPr>
-            <p:ph type="sldNum" sz="quarter" idx="10"/>
-          </p:nvPr>
-        </p:nvSpPr>
-        <p:spPr/>
-        <p:txBody>
-          <a:bodyPr/>
-          <a:lstStyle/>
-          <a:p>
-            <a:fld id="{F7021451-1387-4CA6-816F-3879F97B5CBC}" type="slidenum">
-              <a:rPr lang="en-US"/>
-              <a:t>6</a:t>
-            </a:fld>
-            <a:endParaRPr lang="en-US"/>
-          </a:p>
-        </p:txBody>
-      </p:sp>
-    </p:spTree>
-    <p:extLst>
-      <p:ext uri="{BB962C8B-B14F-4D97-AF65-F5344CB8AC3E}">
-        <p14:creationId xmlns:p14="http://schemas.microsoft.com/office/powerpoint/2010/main" val="1024086991"/>
-      </p:ext>
-    </p:extLst>
-  </p:cSld>
-  <p:clrMapOvr>
-    <a:masterClrMapping/>
-  </p:clrMapOvr>
-</p:notes>
-</file>
-
 <file path=ppt/notesSlides/notesSlide7.xml><?xml version="1.0" encoding="utf-8"?>
 <p:notes xmlns:a="http://schemas.openxmlformats.org/drawingml/2006/main" xmlns:r="http://schemas.openxmlformats.org/officeDocument/2006/relationships" xmlns:p="http://schemas.openxmlformats.org/presentationml/2006/main">
   <p:cSld>
@@ -1600,93 +1512,6 @@
             <a:fld id="{F7021451-1387-4CA6-816F-3879F97B5CBC}" type="slidenum">
               <a:rPr lang="en-US"/>
               <a:t>8</a:t>
-            </a:fld>
-            <a:endParaRPr lang="en-US"/>
-          </a:p>
-        </p:txBody>
-      </p:sp>
-    </p:spTree>
-    <p:extLst>
-      <p:ext uri="{BB962C8B-B14F-4D97-AF65-F5344CB8AC3E}">
-        <p14:creationId xmlns:p14="http://schemas.microsoft.com/office/powerpoint/2010/main" val="1024086991"/>
-      </p:ext>
-    </p:extLst>
-  </p:cSld>
-  <p:clrMapOvr>
-    <a:masterClrMapping/>
-  </p:clrMapOvr>
-</p:notes>
-</file>
-
-<file path=ppt/notesSlides/notesSlide9.xml><?xml version="1.0" encoding="utf-8"?>
-<p:notes xmlns:a="http://schemas.openxmlformats.org/drawingml/2006/main" xmlns:r="http://schemas.openxmlformats.org/officeDocument/2006/relationships" xmlns:p="http://schemas.openxmlformats.org/presentationml/2006/main">
-  <p:cSld>
-    <p:spTree>
-      <p:nvGrpSpPr>
-        <p:cNvPr id="1" name=""/>
-        <p:cNvGrpSpPr/>
-        <p:nvPr/>
-      </p:nvGrpSpPr>
-      <p:grpSpPr>
-        <a:xfrm>
-          <a:off x="0" y="0"/>
-          <a:ext cx="0" cy="0"/>
-          <a:chOff x="0" y="0"/>
-          <a:chExt cx="0" cy="0"/>
-        </a:xfrm>
-      </p:grpSpPr>
-      <p:sp>
-        <p:nvSpPr>
-          <p:cNvPr id="2" name="Slide Image Placeholder 1"/>
-          <p:cNvSpPr>
-            <a:spLocks noGrp="1" noRot="1" noChangeAspect="1"/>
-          </p:cNvSpPr>
-          <p:nvPr>
-            <p:ph type="sldImg"/>
-          </p:nvPr>
-        </p:nvSpPr>
-        <p:spPr/>
-      </p:sp>
-      <p:sp>
-        <p:nvSpPr>
-          <p:cNvPr id="3" name="Notes Placeholder 2"/>
-          <p:cNvSpPr>
-            <a:spLocks noGrp="1"/>
-          </p:cNvSpPr>
-          <p:nvPr>
-            <p:ph type="body" idx="1"/>
-          </p:nvPr>
-        </p:nvSpPr>
-        <p:spPr/>
-        <p:txBody>
-          <a:bodyPr/>
-          <a:lstStyle/>
-          <a:p>
-            <a:r>
-              <a:rPr lang="en-US" dirty="0"/>
-              <a:t>Where it goes next, and the close. The LLM becomes a supplementary tier only for the ~10% the engine can't resolve — complex multi-domain forms like EXACATE/INFSS needing protocol context. The resolution core is unchanged; the LLM only handles what spec matching cannot. Planned use cases: domain disambiguation ('Shortness of Breath' → CE or FA?), MedDRA dictionary resolution by contextual inference, and LLM as a second opinion on low-confidence Tier 2 matches. Broader roadmap: multi-study pattern learning, direct EDC export integration, and the architecture is ready to plug into an AZ-approved LLM endpoint when access lands. Projected resolution 97–99%. Close humbly: this is a first-draft engine with a human in the loop. Thank you — invite questions.</a:t>
-            </a:r>
-          </a:p>
-        </p:txBody>
-      </p:sp>
-      <p:sp>
-        <p:nvSpPr>
-          <p:cNvPr id="4" name="Slide Number Placeholder 3"/>
-          <p:cNvSpPr>
-            <a:spLocks noGrp="1"/>
-          </p:cNvSpPr>
-          <p:nvPr>
-            <p:ph type="sldNum" sz="quarter" idx="10"/>
-          </p:nvPr>
-        </p:nvSpPr>
-        <p:spPr/>
-        <p:txBody>
-          <a:bodyPr/>
-          <a:lstStyle/>
-          <a:p>
-            <a:fld id="{F7021451-1387-4CA6-816F-3879F97B5CBC}" type="slidenum">
-              <a:rPr lang="en-US"/>
-              <a:t>9</a:t>
             </a:fld>
             <a:endParaRPr lang="en-US"/>
           </a:p>
@@ -7737,746 +7562,6 @@
 </p:sld>
 </file>
 
-<file path=ppt/slides/slide6.xml><?xml version="1.0" encoding="utf-8"?>
-<p:sld xmlns:a="http://schemas.openxmlformats.org/drawingml/2006/main" xmlns:r="http://schemas.openxmlformats.org/officeDocument/2006/relationships" xmlns:p="http://schemas.openxmlformats.org/presentationml/2006/main">
-  <p:cSld name="Slide 7">
-    <p:bg>
-      <p:bgPr>
-        <a:solidFill>
-          <a:srgbClr val="FFFFFF"/>
-        </a:solidFill>
-        <a:effectLst/>
-      </p:bgPr>
-    </p:bg>
-    <p:spTree>
-      <p:nvGrpSpPr>
-        <p:cNvPr id="1" name=""/>
-        <p:cNvGrpSpPr/>
-        <p:nvPr/>
-      </p:nvGrpSpPr>
-      <p:grpSpPr>
-        <a:xfrm>
-          <a:off x="0" y="0"/>
-          <a:ext cx="0" cy="0"/>
-          <a:chOff x="0" y="0"/>
-          <a:chExt cx="0" cy="0"/>
-        </a:xfrm>
-      </p:grpSpPr>
-      <p:sp>
-        <p:nvSpPr>
-          <p:cNvPr id="2" name="Text 0"/>
-          <p:cNvSpPr/>
-          <p:nvPr/>
-        </p:nvSpPr>
-        <p:spPr>
-          <a:xfrm>
-            <a:off x="548640" y="384048"/>
-            <a:ext cx="8686800" cy="292608"/>
-          </a:xfrm>
-          <a:prstGeom prst="rect">
-            <a:avLst/>
-          </a:prstGeom>
-          <a:noFill/>
-          <a:ln/>
-        </p:spPr>
-        <p:txBody>
-          <a:bodyPr wrap="square" lIns="0" tIns="0" rIns="0" bIns="0" rtlCol="0" anchor="ctr"/>
-          <a:lstStyle/>
-          <a:p>
-            <a:pPr marL="0" indent="0" algn="l">
-              <a:buNone/>
-            </a:pPr>
-            <a:r>
-              <a:rPr lang="en-US" sz="1200" b="1" kern="0" spc="300" dirty="0">
-                <a:solidFill>
-                  <a:srgbClr val="D0006F"/>
-                </a:solidFill>
-                <a:latin typeface="Calibri" pitchFamily="34" charset="0"/>
-                <a:ea typeface="Calibri" pitchFamily="34" charset="-122"/>
-                <a:cs typeface="Calibri" pitchFamily="34" charset="-120"/>
-              </a:rPr>
-              <a:t>THE RESOLUTION ENGINE</a:t>
-            </a:r>
-            <a:endParaRPr lang="en-US" sz="1200" dirty="0"/>
-          </a:p>
-        </p:txBody>
-      </p:sp>
-      <p:sp>
-        <p:nvSpPr>
-          <p:cNvPr id="3" name="Text 1"/>
-          <p:cNvSpPr/>
-          <p:nvPr/>
-        </p:nvSpPr>
-        <p:spPr>
-          <a:xfrm>
-            <a:off x="548640" y="658368"/>
-            <a:ext cx="10424160" cy="658368"/>
-          </a:xfrm>
-          <a:prstGeom prst="rect">
-            <a:avLst/>
-          </a:prstGeom>
-          <a:noFill/>
-          <a:ln/>
-        </p:spPr>
-        <p:txBody>
-          <a:bodyPr wrap="square" lIns="0" tIns="0" rIns="0" bIns="0" rtlCol="0" anchor="ctr"/>
-          <a:lstStyle/>
-          <a:p>
-            <a:pPr marL="0" indent="0" algn="l">
-              <a:buNone/>
-            </a:pPr>
-            <a:r>
-              <a:rPr lang="en-US" sz="3000" b="1" dirty="0">
-                <a:solidFill>
-                  <a:srgbClr val="830051"/>
-                </a:solidFill>
-                <a:latin typeface="Century Schoolbook" pitchFamily="34" charset="0"/>
-                <a:ea typeface="Century Schoolbook" pitchFamily="34" charset="-122"/>
-                <a:cs typeface="Century Schoolbook" pitchFamily="34" charset="-120"/>
-              </a:rPr>
-              <a:t>A tiered cascade with confidence scoring</a:t>
-            </a:r>
-            <a:endParaRPr lang="en-US" sz="3000" dirty="0"/>
-          </a:p>
-        </p:txBody>
-      </p:sp>
-      <p:sp>
-        <p:nvSpPr>
-          <p:cNvPr id="4" name="Shape 2"/>
-          <p:cNvSpPr/>
-          <p:nvPr/>
-        </p:nvSpPr>
-        <p:spPr>
-          <a:xfrm>
-            <a:off x="11259007" y="420624"/>
-            <a:ext cx="384048" cy="384048"/>
-          </a:xfrm>
-          <a:prstGeom prst="ellipse">
-            <a:avLst/>
-          </a:prstGeom>
-          <a:solidFill>
-            <a:srgbClr val="830051"/>
-          </a:solidFill>
-          <a:ln/>
-        </p:spPr>
-        <p:txBody>
-          <a:bodyPr/>
-          <a:lstStyle/>
-          <a:p>
-            <a:endParaRPr lang="en-IN"/>
-          </a:p>
-        </p:txBody>
-      </p:sp>
-      <p:sp>
-        <p:nvSpPr>
-          <p:cNvPr id="5" name="Text 3"/>
-          <p:cNvSpPr/>
-          <p:nvPr/>
-        </p:nvSpPr>
-        <p:spPr>
-          <a:xfrm>
-            <a:off x="11259007" y="420624"/>
-            <a:ext cx="384048" cy="384048"/>
-          </a:xfrm>
-          <a:prstGeom prst="rect">
-            <a:avLst/>
-          </a:prstGeom>
-          <a:noFill/>
-          <a:ln/>
-        </p:spPr>
-        <p:txBody>
-          <a:bodyPr wrap="square" lIns="0" tIns="0" rIns="0" bIns="0" rtlCol="0" anchor="ctr"/>
-          <a:lstStyle/>
-          <a:p>
-            <a:pPr marL="0" indent="0" algn="ctr">
-              <a:buNone/>
-            </a:pPr>
-            <a:r>
-              <a:rPr lang="en-US" sz="1300" b="1" dirty="0">
-                <a:solidFill>
-                  <a:srgbClr val="FFFFFF"/>
-                </a:solidFill>
-                <a:latin typeface="Calibri" pitchFamily="34" charset="0"/>
-                <a:ea typeface="Calibri" pitchFamily="34" charset="-122"/>
-                <a:cs typeface="Calibri" pitchFamily="34" charset="-120"/>
-              </a:rPr>
-              <a:t>7</a:t>
-            </a:r>
-            <a:endParaRPr lang="en-US" sz="1300" dirty="0"/>
-          </a:p>
-        </p:txBody>
-      </p:sp>
-      <p:sp>
-        <p:nvSpPr>
-          <p:cNvPr id="6" name="Text 4"/>
-          <p:cNvSpPr/>
-          <p:nvPr/>
-        </p:nvSpPr>
-        <p:spPr>
-          <a:xfrm>
-            <a:off x="548640" y="6473952"/>
-            <a:ext cx="8229600" cy="274320"/>
-          </a:xfrm>
-          <a:prstGeom prst="rect">
-            <a:avLst/>
-          </a:prstGeom>
-          <a:noFill/>
-          <a:ln/>
-        </p:spPr>
-        <p:txBody>
-          <a:bodyPr wrap="square" lIns="0" tIns="0" rIns="0" bIns="0" rtlCol="0" anchor="ctr"/>
-          <a:lstStyle/>
-          <a:p>
-            <a:pPr marL="0" indent="0" algn="l">
-              <a:buNone/>
-            </a:pPr>
-            <a:r>
-              <a:rPr lang="en-US" sz="900" b="1" dirty="0">
-                <a:solidFill>
-                  <a:srgbClr val="6B6F72"/>
-                </a:solidFill>
-                <a:latin typeface="Calibri" pitchFamily="34" charset="0"/>
-                <a:ea typeface="Calibri" pitchFamily="34" charset="-122"/>
-                <a:cs typeface="Calibri" pitchFamily="34" charset="-120"/>
-              </a:rPr>
-              <a:t>Automated aCRF Annotation Engine</a:t>
-            </a:r>
-            <a:r>
-              <a:rPr lang="en-US" sz="900" dirty="0">
-                <a:solidFill>
-                  <a:srgbClr val="9DB0AC"/>
-                </a:solidFill>
-                <a:latin typeface="Calibri" pitchFamily="34" charset="0"/>
-                <a:ea typeface="Calibri" pitchFamily="34" charset="-122"/>
-                <a:cs typeface="Calibri" pitchFamily="34" charset="-120"/>
-              </a:rPr>
-              <a:t>   ·   AstraZeneca  ·  R&amp;I Statistical Programming</a:t>
-            </a:r>
-            <a:endParaRPr lang="en-US" sz="900" dirty="0"/>
-          </a:p>
-        </p:txBody>
-      </p:sp>
-      <p:sp>
-        <p:nvSpPr>
-          <p:cNvPr id="7" name="Text 5"/>
-          <p:cNvSpPr/>
-          <p:nvPr/>
-        </p:nvSpPr>
-        <p:spPr>
-          <a:xfrm>
-            <a:off x="548640" y="1444752"/>
-            <a:ext cx="11094415" cy="457200"/>
-          </a:xfrm>
-          <a:prstGeom prst="rect">
-            <a:avLst/>
-          </a:prstGeom>
-          <a:noFill/>
-          <a:ln/>
-        </p:spPr>
-        <p:txBody>
-          <a:bodyPr wrap="square" lIns="0" tIns="0" rIns="0" bIns="0" rtlCol="0" anchor="t"/>
-          <a:lstStyle/>
-          <a:p>
-            <a:pPr marL="0" indent="0" algn="l">
-              <a:lnSpc>
-                <a:spcPct val="102000"/>
-              </a:lnSpc>
-              <a:buNone/>
-            </a:pPr>
-            <a:r>
-              <a:rPr lang="en-US" sz="1300" dirty="0">
-                <a:solidFill>
-                  <a:srgbClr val="6B6F72"/>
-                </a:solidFill>
-                <a:latin typeface="Calibri" pitchFamily="34" charset="0"/>
-                <a:ea typeface="Calibri" pitchFamily="34" charset="-122"/>
-                <a:cs typeface="Calibri" pitchFamily="34" charset="-120"/>
-              </a:rPr>
-              <a:t>Fields escalate to the next tier only if unresolved by the previous one — each tier assigns a confidence score, and net automation reaches ~90% with ~10% routed to manual review.</a:t>
-            </a:r>
-            <a:endParaRPr lang="en-US" sz="1300" dirty="0"/>
-          </a:p>
-        </p:txBody>
-      </p:sp>
-      <p:pic>
-        <p:nvPicPr>
-          <p:cNvPr id="8" name="Image 0" descr="/tmp/build/assets/resolution_engine.png"/>
-          <p:cNvPicPr>
-            <a:picLocks noChangeAspect="1"/>
-          </p:cNvPicPr>
-          <p:nvPr/>
-        </p:nvPicPr>
-        <p:blipFill>
-          <a:blip r:embed="rId3"/>
-          <a:stretch>
-            <a:fillRect/>
-          </a:stretch>
-        </p:blipFill>
-        <p:spPr>
-          <a:xfrm>
-            <a:off x="883768" y="1938528"/>
-            <a:ext cx="10424160" cy="3510109"/>
-          </a:xfrm>
-          <a:prstGeom prst="rect">
-            <a:avLst/>
-          </a:prstGeom>
-        </p:spPr>
-      </p:pic>
-      <p:sp>
-        <p:nvSpPr>
-          <p:cNvPr id="9" name="Shape 6"/>
-          <p:cNvSpPr/>
-          <p:nvPr/>
-        </p:nvSpPr>
-        <p:spPr>
-          <a:xfrm>
-            <a:off x="548640" y="5631517"/>
-            <a:ext cx="841248" cy="274320"/>
-          </a:xfrm>
-          <a:prstGeom prst="roundRect">
-            <a:avLst>
-              <a:gd name="adj" fmla="val 50000"/>
-            </a:avLst>
-          </a:prstGeom>
-          <a:solidFill>
-            <a:srgbClr val="003865"/>
-          </a:solidFill>
-          <a:ln/>
-        </p:spPr>
-        <p:txBody>
-          <a:bodyPr/>
-          <a:lstStyle/>
-          <a:p>
-            <a:endParaRPr lang="en-IN"/>
-          </a:p>
-        </p:txBody>
-      </p:sp>
-      <p:sp>
-        <p:nvSpPr>
-          <p:cNvPr id="10" name="Text 7"/>
-          <p:cNvSpPr/>
-          <p:nvPr/>
-        </p:nvSpPr>
-        <p:spPr>
-          <a:xfrm>
-            <a:off x="548640" y="5631517"/>
-            <a:ext cx="841248" cy="274320"/>
-          </a:xfrm>
-          <a:prstGeom prst="rect">
-            <a:avLst/>
-          </a:prstGeom>
-          <a:noFill/>
-          <a:ln/>
-        </p:spPr>
-        <p:txBody>
-          <a:bodyPr wrap="square" lIns="0" tIns="0" rIns="0" bIns="0" rtlCol="0" anchor="ctr"/>
-          <a:lstStyle/>
-          <a:p>
-            <a:pPr marL="0" indent="0" algn="ctr">
-              <a:buNone/>
-            </a:pPr>
-            <a:r>
-              <a:rPr lang="en-US" sz="950" b="1" kern="0" spc="100" dirty="0">
-                <a:solidFill>
-                  <a:srgbClr val="FFFFFF"/>
-                </a:solidFill>
-                <a:latin typeface="Calibri" pitchFamily="34" charset="0"/>
-                <a:ea typeface="Calibri" pitchFamily="34" charset="-122"/>
-                <a:cs typeface="Calibri" pitchFamily="34" charset="-120"/>
-              </a:rPr>
-              <a:t>TIER 0</a:t>
-            </a:r>
-            <a:endParaRPr lang="en-US" sz="950" dirty="0"/>
-          </a:p>
-        </p:txBody>
-      </p:sp>
-      <p:sp>
-        <p:nvSpPr>
-          <p:cNvPr id="11" name="Text 8"/>
-          <p:cNvSpPr/>
-          <p:nvPr/>
-        </p:nvSpPr>
-        <p:spPr>
-          <a:xfrm>
-            <a:off x="1481328" y="5613229"/>
-            <a:ext cx="2460650" cy="310896"/>
-          </a:xfrm>
-          <a:prstGeom prst="rect">
-            <a:avLst/>
-          </a:prstGeom>
-          <a:noFill/>
-          <a:ln/>
-        </p:spPr>
-        <p:txBody>
-          <a:bodyPr wrap="square" lIns="0" tIns="0" rIns="0" bIns="0" rtlCol="0" anchor="ctr"/>
-          <a:lstStyle/>
-          <a:p>
-            <a:pPr marL="0" indent="0" algn="l">
-              <a:buNone/>
-            </a:pPr>
-            <a:r>
-              <a:rPr lang="en-US" sz="1250" b="1" dirty="0">
-                <a:solidFill>
-                  <a:srgbClr val="2B2B2B"/>
-                </a:solidFill>
-                <a:latin typeface="Century Schoolbook" pitchFamily="34" charset="0"/>
-                <a:ea typeface="Century Schoolbook" pitchFamily="34" charset="-122"/>
-                <a:cs typeface="Century Schoolbook" pitchFamily="34" charset="-120"/>
-              </a:rPr>
-              <a:t>Form-scoped match</a:t>
-            </a:r>
-            <a:endParaRPr lang="en-US" sz="1250" dirty="0"/>
-          </a:p>
-        </p:txBody>
-      </p:sp>
-      <p:sp>
-        <p:nvSpPr>
-          <p:cNvPr id="12" name="Text 9"/>
-          <p:cNvSpPr/>
-          <p:nvPr/>
-        </p:nvSpPr>
-        <p:spPr>
-          <a:xfrm>
-            <a:off x="548640" y="5924125"/>
-            <a:ext cx="3393338" cy="548640"/>
-          </a:xfrm>
-          <a:prstGeom prst="rect">
-            <a:avLst/>
-          </a:prstGeom>
-          <a:noFill/>
-          <a:ln/>
-        </p:spPr>
-        <p:txBody>
-          <a:bodyPr wrap="square" lIns="0" tIns="0" rIns="0" bIns="0" rtlCol="0" anchor="t"/>
-          <a:lstStyle/>
-          <a:p>
-            <a:pPr marL="0" indent="0" algn="l">
-              <a:lnSpc>
-                <a:spcPct val="98000"/>
-              </a:lnSpc>
-              <a:buNone/>
-            </a:pPr>
-            <a:r>
-              <a:rPr lang="en-US" sz="960" dirty="0">
-                <a:solidFill>
-                  <a:srgbClr val="6B6F72"/>
-                </a:solidFill>
-                <a:latin typeface="Calibri" pitchFamily="34" charset="0"/>
-                <a:ea typeface="Calibri" pitchFamily="34" charset="-122"/>
-                <a:cs typeface="Calibri" pitchFamily="34" charset="-120"/>
-              </a:rPr>
-              <a:t>Reads the form code from the page header, scopes to that form's mappings, and matches the field label — exact, context-verified.</a:t>
-            </a:r>
-            <a:endParaRPr lang="en-US" sz="960" dirty="0"/>
-          </a:p>
-        </p:txBody>
-      </p:sp>
-      <p:sp>
-        <p:nvSpPr>
-          <p:cNvPr id="13" name="Shape 10"/>
-          <p:cNvSpPr/>
-          <p:nvPr/>
-        </p:nvSpPr>
-        <p:spPr>
-          <a:xfrm>
-            <a:off x="4399178" y="5631517"/>
-            <a:ext cx="841248" cy="274320"/>
-          </a:xfrm>
-          <a:prstGeom prst="roundRect">
-            <a:avLst>
-              <a:gd name="adj" fmla="val 50000"/>
-            </a:avLst>
-          </a:prstGeom>
-          <a:solidFill>
-            <a:srgbClr val="830051"/>
-          </a:solidFill>
-          <a:ln/>
-        </p:spPr>
-        <p:txBody>
-          <a:bodyPr/>
-          <a:lstStyle/>
-          <a:p>
-            <a:endParaRPr lang="en-IN"/>
-          </a:p>
-        </p:txBody>
-      </p:sp>
-      <p:sp>
-        <p:nvSpPr>
-          <p:cNvPr id="14" name="Text 11"/>
-          <p:cNvSpPr/>
-          <p:nvPr/>
-        </p:nvSpPr>
-        <p:spPr>
-          <a:xfrm>
-            <a:off x="4399178" y="5631517"/>
-            <a:ext cx="841248" cy="274320"/>
-          </a:xfrm>
-          <a:prstGeom prst="rect">
-            <a:avLst/>
-          </a:prstGeom>
-          <a:noFill/>
-          <a:ln/>
-        </p:spPr>
-        <p:txBody>
-          <a:bodyPr wrap="square" lIns="0" tIns="0" rIns="0" bIns="0" rtlCol="0" anchor="ctr"/>
-          <a:lstStyle/>
-          <a:p>
-            <a:pPr marL="0" indent="0" algn="ctr">
-              <a:buNone/>
-            </a:pPr>
-            <a:r>
-              <a:rPr lang="en-US" sz="950" b="1" kern="0" spc="100" dirty="0">
-                <a:solidFill>
-                  <a:srgbClr val="FFFFFF"/>
-                </a:solidFill>
-                <a:latin typeface="Calibri" pitchFamily="34" charset="0"/>
-                <a:ea typeface="Calibri" pitchFamily="34" charset="-122"/>
-                <a:cs typeface="Calibri" pitchFamily="34" charset="-120"/>
-              </a:rPr>
-              <a:t>TIER 1</a:t>
-            </a:r>
-            <a:endParaRPr lang="en-US" sz="950" dirty="0"/>
-          </a:p>
-        </p:txBody>
-      </p:sp>
-      <p:sp>
-        <p:nvSpPr>
-          <p:cNvPr id="15" name="Text 12"/>
-          <p:cNvSpPr/>
-          <p:nvPr/>
-        </p:nvSpPr>
-        <p:spPr>
-          <a:xfrm>
-            <a:off x="5331866" y="5613229"/>
-            <a:ext cx="2460650" cy="310896"/>
-          </a:xfrm>
-          <a:prstGeom prst="rect">
-            <a:avLst/>
-          </a:prstGeom>
-          <a:noFill/>
-          <a:ln/>
-        </p:spPr>
-        <p:txBody>
-          <a:bodyPr wrap="square" lIns="0" tIns="0" rIns="0" bIns="0" rtlCol="0" anchor="ctr"/>
-          <a:lstStyle/>
-          <a:p>
-            <a:pPr marL="0" indent="0" algn="l">
-              <a:buNone/>
-            </a:pPr>
-            <a:r>
-              <a:rPr lang="en-US" sz="1250" b="1" dirty="0">
-                <a:solidFill>
-                  <a:srgbClr val="2B2B2B"/>
-                </a:solidFill>
-                <a:latin typeface="Century Schoolbook" pitchFamily="34" charset="0"/>
-                <a:ea typeface="Century Schoolbook" pitchFamily="34" charset="-122"/>
-                <a:cs typeface="Century Schoolbook" pitchFamily="34" charset="-120"/>
-              </a:rPr>
-              <a:t>NOT SUBMITTED</a:t>
-            </a:r>
-            <a:endParaRPr lang="en-US" sz="1250" dirty="0"/>
-          </a:p>
-        </p:txBody>
-      </p:sp>
-      <p:sp>
-        <p:nvSpPr>
-          <p:cNvPr id="16" name="Text 13"/>
-          <p:cNvSpPr/>
-          <p:nvPr/>
-        </p:nvSpPr>
-        <p:spPr>
-          <a:xfrm>
-            <a:off x="4399178" y="5924125"/>
-            <a:ext cx="3393338" cy="548640"/>
-          </a:xfrm>
-          <a:prstGeom prst="rect">
-            <a:avLst/>
-          </a:prstGeom>
-          <a:noFill/>
-          <a:ln/>
-        </p:spPr>
-        <p:txBody>
-          <a:bodyPr wrap="square" lIns="0" tIns="0" rIns="0" bIns="0" rtlCol="0" anchor="t"/>
-          <a:lstStyle/>
-          <a:p>
-            <a:pPr marL="0" indent="0" algn="l">
-              <a:lnSpc>
-                <a:spcPct val="98000"/>
-              </a:lnSpc>
-              <a:buNone/>
-            </a:pPr>
-            <a:r>
-              <a:rPr lang="en-US" sz="960" dirty="0">
-                <a:solidFill>
-                  <a:srgbClr val="6B6F72"/>
-                </a:solidFill>
-                <a:latin typeface="Calibri" pitchFamily="34" charset="0"/>
-                <a:ea typeface="Calibri" pitchFamily="34" charset="-122"/>
-                <a:cs typeface="Calibri" pitchFamily="34" charset="-120"/>
-              </a:rPr>
-              <a:t>Catches fields that should never map — e.g. "Field created for RSG to calculate height" — instead of forcing a wrong mapping.</a:t>
-            </a:r>
-            <a:endParaRPr lang="en-US" sz="960" dirty="0"/>
-          </a:p>
-        </p:txBody>
-      </p:sp>
-      <p:sp>
-        <p:nvSpPr>
-          <p:cNvPr id="17" name="Shape 14"/>
-          <p:cNvSpPr/>
-          <p:nvPr/>
-        </p:nvSpPr>
-        <p:spPr>
-          <a:xfrm>
-            <a:off x="8249717" y="5631517"/>
-            <a:ext cx="841248" cy="274320"/>
-          </a:xfrm>
-          <a:prstGeom prst="roundRect">
-            <a:avLst>
-              <a:gd name="adj" fmla="val 50000"/>
-            </a:avLst>
-          </a:prstGeom>
-          <a:solidFill>
-            <a:srgbClr val="F0AB00"/>
-          </a:solidFill>
-          <a:ln/>
-        </p:spPr>
-        <p:txBody>
-          <a:bodyPr/>
-          <a:lstStyle/>
-          <a:p>
-            <a:endParaRPr lang="en-IN"/>
-          </a:p>
-        </p:txBody>
-      </p:sp>
-      <p:sp>
-        <p:nvSpPr>
-          <p:cNvPr id="18" name="Text 15"/>
-          <p:cNvSpPr/>
-          <p:nvPr/>
-        </p:nvSpPr>
-        <p:spPr>
-          <a:xfrm>
-            <a:off x="8249717" y="5631517"/>
-            <a:ext cx="841248" cy="274320"/>
-          </a:xfrm>
-          <a:prstGeom prst="rect">
-            <a:avLst/>
-          </a:prstGeom>
-          <a:noFill/>
-          <a:ln/>
-        </p:spPr>
-        <p:txBody>
-          <a:bodyPr wrap="square" lIns="0" tIns="0" rIns="0" bIns="0" rtlCol="0" anchor="ctr"/>
-          <a:lstStyle/>
-          <a:p>
-            <a:pPr marL="0" indent="0" algn="ctr">
-              <a:buNone/>
-            </a:pPr>
-            <a:r>
-              <a:rPr lang="en-US" sz="950" b="1" kern="0" spc="100" dirty="0">
-                <a:solidFill>
-                  <a:srgbClr val="FFFFFF"/>
-                </a:solidFill>
-                <a:latin typeface="Calibri" pitchFamily="34" charset="0"/>
-                <a:ea typeface="Calibri" pitchFamily="34" charset="-122"/>
-                <a:cs typeface="Calibri" pitchFamily="34" charset="-120"/>
-              </a:rPr>
-              <a:t>TIER 2</a:t>
-            </a:r>
-            <a:endParaRPr lang="en-US" sz="950" dirty="0"/>
-          </a:p>
-        </p:txBody>
-      </p:sp>
-      <p:sp>
-        <p:nvSpPr>
-          <p:cNvPr id="19" name="Text 16"/>
-          <p:cNvSpPr/>
-          <p:nvPr/>
-        </p:nvSpPr>
-        <p:spPr>
-          <a:xfrm>
-            <a:off x="9182405" y="5613229"/>
-            <a:ext cx="2460650" cy="310896"/>
-          </a:xfrm>
-          <a:prstGeom prst="rect">
-            <a:avLst/>
-          </a:prstGeom>
-          <a:noFill/>
-          <a:ln/>
-        </p:spPr>
-        <p:txBody>
-          <a:bodyPr wrap="square" lIns="0" tIns="0" rIns="0" bIns="0" rtlCol="0" anchor="ctr"/>
-          <a:lstStyle/>
-          <a:p>
-            <a:pPr marL="0" indent="0" algn="l">
-              <a:buNone/>
-            </a:pPr>
-            <a:r>
-              <a:rPr lang="en-US" sz="1250" b="1" dirty="0">
-                <a:solidFill>
-                  <a:srgbClr val="2B2B2B"/>
-                </a:solidFill>
-                <a:latin typeface="Century Schoolbook" pitchFamily="34" charset="0"/>
-                <a:ea typeface="Century Schoolbook" pitchFamily="34" charset="-122"/>
-                <a:cs typeface="Century Schoolbook" pitchFamily="34" charset="-120"/>
-              </a:rPr>
-              <a:t>Cross-module fuzzy match</a:t>
-            </a:r>
-            <a:endParaRPr lang="en-US" sz="1250" dirty="0"/>
-          </a:p>
-        </p:txBody>
-      </p:sp>
-      <p:sp>
-        <p:nvSpPr>
-          <p:cNvPr id="20" name="Text 17"/>
-          <p:cNvSpPr/>
-          <p:nvPr/>
-        </p:nvSpPr>
-        <p:spPr>
-          <a:xfrm>
-            <a:off x="8249717" y="5924125"/>
-            <a:ext cx="3393338" cy="548640"/>
-          </a:xfrm>
-          <a:prstGeom prst="rect">
-            <a:avLst/>
-          </a:prstGeom>
-          <a:noFill/>
-          <a:ln/>
-        </p:spPr>
-        <p:txBody>
-          <a:bodyPr wrap="square" lIns="0" tIns="0" rIns="0" bIns="0" rtlCol="0" anchor="t"/>
-          <a:lstStyle/>
-          <a:p>
-            <a:pPr marL="0" indent="0" algn="l">
-              <a:lnSpc>
-                <a:spcPct val="98000"/>
-              </a:lnSpc>
-              <a:buNone/>
-            </a:pPr>
-            <a:r>
-              <a:rPr lang="en-US" sz="960" dirty="0">
-                <a:solidFill>
-                  <a:srgbClr val="6B6F72"/>
-                </a:solidFill>
-                <a:latin typeface="Calibri" pitchFamily="34" charset="0"/>
-                <a:ea typeface="Calibri" pitchFamily="34" charset="-122"/>
-                <a:cs typeface="Calibri" pitchFamily="34" charset="-120"/>
-              </a:rPr>
-              <a:t>Searches all spec modules for in-form leftovers; accepts only above threshold, else leaves it flagged for the programmer.</a:t>
-            </a:r>
-            <a:endParaRPr lang="en-US" sz="960" dirty="0"/>
-          </a:p>
-        </p:txBody>
-      </p:sp>
-    </p:spTree>
-  </p:cSld>
-  <p:clrMapOvr>
-    <a:masterClrMapping/>
-  </p:clrMapOvr>
-</p:sld>
-</file>
-
 <file path=ppt/slides/slide7.xml><?xml version="1.0" encoding="utf-8"?>
 <p:sld xmlns:a="http://schemas.openxmlformats.org/drawingml/2006/main" xmlns:r="http://schemas.openxmlformats.org/officeDocument/2006/relationships" xmlns:p="http://schemas.openxmlformats.org/presentationml/2006/main">
   <p:cSld name="Slide 10">
@@ -9400,7 +8485,7 @@
                 <a:ea typeface="Calibri" pitchFamily="34" charset="-122"/>
                 <a:cs typeface="Calibri" pitchFamily="34" charset="-120"/>
               </a:rPr>
-              <a:t>WHERE IT STANDS TODAY</a:t>
+              <a:t>WHERE IT STANDS &amp; WHAT'S NEXT</a:t>
             </a:r>
             <a:endParaRPr lang="en-US" sz="1200" dirty="0"/>
           </a:p>
@@ -9439,7 +8524,7 @@
                 <a:ea typeface="Century Schoolbook" pitchFamily="34" charset="-122"/>
                 <a:cs typeface="Century Schoolbook" pitchFamily="34" charset="-120"/>
               </a:rPr>
-              <a:t>Summary &amp; refinement areas</a:t>
+              <a:t>Summary, refinement areas &amp; next step</a:t>
             </a:r>
             <a:endParaRPr lang="en-US" sz="3000" dirty="0"/>
           </a:p>
@@ -10554,7 +9639,7 @@
                 <a:ea typeface="Century Schoolbook" pitchFamily="34" charset="-122"/>
                 <a:cs typeface="Century Schoolbook" pitchFamily="34" charset="-120"/>
               </a:rPr>
-              <a:t>Refinement areas — where study-level context is still needed</a:t>
+              <a:t>Refinement areas &amp; next step</a:t>
             </a:r>
             <a:endParaRPr lang="en-US" sz="1450" dirty="0"/>
           </a:p>
@@ -10656,7 +9741,7 @@
                 <a:ea typeface="Century Schoolbook" pitchFamily="34" charset="-122"/>
                 <a:cs typeface="Century Schoolbook" pitchFamily="34" charset="-120"/>
               </a:rPr>
-              <a:t>Gating questions</a:t>
+              <a:t>Multi-domain forms</a:t>
             </a:r>
             <a:endParaRPr lang="en-US" sz="1400" dirty="0"/>
           </a:p>
@@ -10698,7 +9783,7 @@
                 <a:ea typeface="Calibri" pitchFamily="34" charset="-122"/>
                 <a:cs typeface="Calibri" pitchFamily="34" charset="-120"/>
               </a:rPr>
-              <a:t>Yes/No fields that trigger a section sometimes map to the topic variable instead of NOT SUBMITTED — distinguishing them needs study-level context.</a:t>
+              <a:t>Fields that could fit two domains (CE / FA / MH) need protocol context.</a:t>
             </a:r>
             <a:endParaRPr lang="en-US" sz="1100" dirty="0"/>
           </a:p>
@@ -10800,7 +9885,7 @@
                 <a:ea typeface="Century Schoolbook" pitchFamily="34" charset="-122"/>
                 <a:cs typeface="Century Schoolbook" pitchFamily="34" charset="-120"/>
               </a:rPr>
-              <a:t>Supplemental qualifiers</a:t>
+              <a:t>Gating &amp; supplemental fields</a:t>
             </a:r>
             <a:endParaRPr lang="en-US" sz="1400" dirty="0"/>
           </a:p>
@@ -10842,7 +9927,7 @@
                 <a:ea typeface="Calibri" pitchFamily="34" charset="-122"/>
                 <a:cs typeface="Calibri" pitchFamily="34" charset="-120"/>
               </a:rPr>
-              <a:t>SUPP-- variables need extra spec detail for fields like "Reason not performed" and processing date/time fields.</a:t>
+              <a:t>Some Yes/No triggers and SUPP-- fields need extra spec detail.</a:t>
             </a:r>
             <a:endParaRPr lang="en-US" sz="1100" dirty="0"/>
           </a:p>
@@ -10944,7 +10029,7 @@
                 <a:ea typeface="Century Schoolbook" pitchFamily="34" charset="-122"/>
                 <a:cs typeface="Century Schoolbook" pitchFamily="34" charset="-120"/>
               </a:rPr>
-              <a:t>Duplicate assignments</a:t>
+              <a:t>Duplicate labels</a:t>
             </a:r>
             <a:endParaRPr lang="en-US" sz="1400" dirty="0"/>
           </a:p>
@@ -10986,7 +10071,7 @@
                 <a:ea typeface="Calibri" pitchFamily="34" charset="-122"/>
                 <a:cs typeface="Calibri" pitchFamily="34" charset="-120"/>
               </a:rPr>
-              <a:t>Forms where one label serves two purposes (coded result vs free-text reason) — resolvable with field-type awareness.</a:t>
+              <a:t>One label used two ways (coded vs free text) — field-type awareness planned.</a:t>
             </a:r>
             <a:endParaRPr lang="en-US" sz="1100" dirty="0"/>
           </a:p>
@@ -11088,7 +10173,7 @@
                 <a:ea typeface="Century Schoolbook" pitchFamily="34" charset="-122"/>
                 <a:cs typeface="Century Schoolbook" pitchFamily="34" charset="-120"/>
               </a:rPr>
-              <a:t>Multi-domain forms</a:t>
+              <a:t>Next step — LLM assist (→ 97–99%)</a:t>
             </a:r>
             <a:endParaRPr lang="en-US" sz="1400" dirty="0"/>
           </a:p>
@@ -11130,955 +10215,9 @@
                 <a:ea typeface="Calibri" pitchFamily="34" charset="-122"/>
                 <a:cs typeface="Calibri" pitchFamily="34" charset="-120"/>
               </a:rPr>
-              <a:t>EXACATE, INFSS, LIVERSS where a field could be CE, FA or MH — needs protocol context to disambiguate.</a:t>
+              <a:t>AZ-approved LLM for the unresolved ~10% only (multi-domain disambiguation, MedDRA fields, low-confidence checks). Core stays standards-based &amp; traceable. Permission requested.</a:t>
             </a:r>
             <a:endParaRPr lang="en-US" sz="1100" dirty="0"/>
-          </a:p>
-        </p:txBody>
-      </p:sp>
-    </p:spTree>
-  </p:cSld>
-  <p:clrMapOvr>
-    <a:masterClrMapping/>
-  </p:clrMapOvr>
-</p:sld>
-</file>
-
-<file path=ppt/slides/slide9.xml><?xml version="1.0" encoding="utf-8"?>
-<p:sld xmlns:a="http://schemas.openxmlformats.org/drawingml/2006/main" xmlns:r="http://schemas.openxmlformats.org/officeDocument/2006/relationships" xmlns:p="http://schemas.openxmlformats.org/presentationml/2006/main">
-  <p:cSld name="Slide 12">
-    <p:bg>
-      <p:bgPr>
-        <a:solidFill>
-          <a:srgbClr val="830051"/>
-        </a:solidFill>
-        <a:effectLst/>
-      </p:bgPr>
-    </p:bg>
-    <p:spTree>
-      <p:nvGrpSpPr>
-        <p:cNvPr id="1" name=""/>
-        <p:cNvGrpSpPr/>
-        <p:nvPr/>
-      </p:nvGrpSpPr>
-      <p:grpSpPr>
-        <a:xfrm>
-          <a:off x="0" y="0"/>
-          <a:ext cx="0" cy="0"/>
-          <a:chOff x="0" y="0"/>
-          <a:chExt cx="0" cy="0"/>
-        </a:xfrm>
-      </p:grpSpPr>
-      <p:sp>
-        <p:nvSpPr>
-          <p:cNvPr id="2" name="Text 0"/>
-          <p:cNvSpPr/>
-          <p:nvPr/>
-        </p:nvSpPr>
-        <p:spPr>
-          <a:xfrm>
-            <a:off x="548640" y="420624"/>
-            <a:ext cx="8229600" cy="292608"/>
-          </a:xfrm>
-          <a:prstGeom prst="rect">
-            <a:avLst/>
-          </a:prstGeom>
-          <a:noFill/>
-          <a:ln/>
-        </p:spPr>
-        <p:txBody>
-          <a:bodyPr wrap="square" lIns="0" tIns="0" rIns="0" bIns="0" rtlCol="0" anchor="ctr"/>
-          <a:lstStyle/>
-          <a:p>
-            <a:pPr marL="0" indent="0" algn="l">
-              <a:buNone/>
-            </a:pPr>
-            <a:r>
-              <a:rPr lang="en-US" sz="1200" b="1" kern="0" spc="300" dirty="0">
-                <a:solidFill>
-                  <a:srgbClr val="68D2DF"/>
-                </a:solidFill>
-                <a:latin typeface="Calibri" pitchFamily="34" charset="0"/>
-                <a:ea typeface="Calibri" pitchFamily="34" charset="-122"/>
-                <a:cs typeface="Calibri" pitchFamily="34" charset="-120"/>
-              </a:rPr>
-              <a:t>WHERE IT GOES NEXT</a:t>
-            </a:r>
-            <a:endParaRPr lang="en-US" sz="1200" dirty="0"/>
-          </a:p>
-        </p:txBody>
-      </p:sp>
-      <p:sp>
-        <p:nvSpPr>
-          <p:cNvPr id="3" name="Text 1"/>
-          <p:cNvSpPr/>
-          <p:nvPr/>
-        </p:nvSpPr>
-        <p:spPr>
-          <a:xfrm>
-            <a:off x="548640" y="713232"/>
-            <a:ext cx="10058400" cy="658368"/>
-          </a:xfrm>
-          <a:prstGeom prst="rect">
-            <a:avLst/>
-          </a:prstGeom>
-          <a:noFill/>
-          <a:ln/>
-        </p:spPr>
-        <p:txBody>
-          <a:bodyPr wrap="square" lIns="0" tIns="0" rIns="0" bIns="0" rtlCol="0" anchor="ctr"/>
-          <a:lstStyle/>
-          <a:p>
-            <a:pPr marL="0" indent="0" algn="l">
-              <a:buNone/>
-            </a:pPr>
-            <a:r>
-              <a:rPr lang="en-US" sz="3000" b="1" dirty="0">
-                <a:solidFill>
-                  <a:srgbClr val="FFFFFF"/>
-                </a:solidFill>
-                <a:latin typeface="Century Schoolbook" pitchFamily="34" charset="0"/>
-                <a:ea typeface="Century Schoolbook" pitchFamily="34" charset="-122"/>
-                <a:cs typeface="Century Schoolbook" pitchFamily="34" charset="-120"/>
-              </a:rPr>
-              <a:t>Future enhancements</a:t>
-            </a:r>
-            <a:endParaRPr lang="en-US" sz="3000" dirty="0"/>
-          </a:p>
-        </p:txBody>
-      </p:sp>
-      <p:sp>
-        <p:nvSpPr>
-          <p:cNvPr id="4" name="Shape 2"/>
-          <p:cNvSpPr/>
-          <p:nvPr/>
-        </p:nvSpPr>
-        <p:spPr>
-          <a:xfrm>
-            <a:off x="11259007" y="457200"/>
-            <a:ext cx="384048" cy="384048"/>
-          </a:xfrm>
-          <a:prstGeom prst="ellipse">
-            <a:avLst/>
-          </a:prstGeom>
-          <a:solidFill>
-            <a:srgbClr val="FFFFFF"/>
-          </a:solidFill>
-          <a:ln/>
-        </p:spPr>
-        <p:txBody>
-          <a:bodyPr/>
-          <a:lstStyle/>
-          <a:p>
-            <a:endParaRPr lang="en-IN"/>
-          </a:p>
-        </p:txBody>
-      </p:sp>
-      <p:sp>
-        <p:nvSpPr>
-          <p:cNvPr id="5" name="Text 3"/>
-          <p:cNvSpPr/>
-          <p:nvPr/>
-        </p:nvSpPr>
-        <p:spPr>
-          <a:xfrm>
-            <a:off x="11259007" y="457200"/>
-            <a:ext cx="384048" cy="384048"/>
-          </a:xfrm>
-          <a:prstGeom prst="rect">
-            <a:avLst/>
-          </a:prstGeom>
-          <a:noFill/>
-          <a:ln/>
-        </p:spPr>
-        <p:txBody>
-          <a:bodyPr wrap="square" lIns="0" tIns="0" rIns="0" bIns="0" rtlCol="0" anchor="ctr"/>
-          <a:lstStyle/>
-          <a:p>
-            <a:pPr marL="0" indent="0" algn="ctr">
-              <a:buNone/>
-            </a:pPr>
-            <a:r>
-              <a:rPr lang="en-US" sz="1300" b="1" dirty="0">
-                <a:solidFill>
-                  <a:srgbClr val="830051"/>
-                </a:solidFill>
-                <a:latin typeface="Calibri" pitchFamily="34" charset="0"/>
-                <a:ea typeface="Calibri" pitchFamily="34" charset="-122"/>
-                <a:cs typeface="Calibri" pitchFamily="34" charset="-120"/>
-              </a:rPr>
-              <a:t>12</a:t>
-            </a:r>
-            <a:endParaRPr lang="en-US" sz="1300" dirty="0"/>
-          </a:p>
-        </p:txBody>
-      </p:sp>
-      <p:sp>
-        <p:nvSpPr>
-          <p:cNvPr id="6" name="Shape 4"/>
-          <p:cNvSpPr/>
-          <p:nvPr/>
-        </p:nvSpPr>
-        <p:spPr>
-          <a:xfrm>
-            <a:off x="548640" y="1572768"/>
-            <a:ext cx="11094415" cy="1078992"/>
-          </a:xfrm>
-          <a:prstGeom prst="roundRect">
-            <a:avLst>
-              <a:gd name="adj" fmla="val 10169"/>
-            </a:avLst>
-          </a:prstGeom>
-          <a:solidFill>
-            <a:srgbClr val="FFFFFF">
-              <a:alpha val="10000"/>
-            </a:srgbClr>
-          </a:solidFill>
-          <a:ln w="12700">
-            <a:solidFill>
-              <a:srgbClr val="D0006F"/>
-            </a:solidFill>
-            <a:prstDash val="solid"/>
-          </a:ln>
-        </p:spPr>
-        <p:txBody>
-          <a:bodyPr/>
-          <a:lstStyle/>
-          <a:p>
-            <a:endParaRPr lang="en-IN"/>
-          </a:p>
-        </p:txBody>
-      </p:sp>
-      <p:sp>
-        <p:nvSpPr>
-          <p:cNvPr id="7" name="Shape 5"/>
-          <p:cNvSpPr/>
-          <p:nvPr/>
-        </p:nvSpPr>
-        <p:spPr>
-          <a:xfrm>
-            <a:off x="859536" y="1847088"/>
-            <a:ext cx="548640" cy="548640"/>
-          </a:xfrm>
-          <a:prstGeom prst="ellipse">
-            <a:avLst/>
-          </a:prstGeom>
-          <a:solidFill>
-            <a:srgbClr val="D0006F"/>
-          </a:solidFill>
-          <a:ln/>
-        </p:spPr>
-        <p:txBody>
-          <a:bodyPr/>
-          <a:lstStyle/>
-          <a:p>
-            <a:endParaRPr lang="en-IN"/>
-          </a:p>
-        </p:txBody>
-      </p:sp>
-      <p:pic>
-        <p:nvPicPr>
-          <p:cNvPr id="8" name="Image 0" descr="/tmp/build/icons/bulb_white.png"/>
-          <p:cNvPicPr>
-            <a:picLocks noChangeAspect="1"/>
-          </p:cNvPicPr>
-          <p:nvPr/>
-        </p:nvPicPr>
-        <p:blipFill>
-          <a:blip r:embed="rId3"/>
-          <a:stretch>
-            <a:fillRect/>
-          </a:stretch>
-        </p:blipFill>
-        <p:spPr>
-          <a:xfrm>
-            <a:off x="1002182" y="1989734"/>
-            <a:ext cx="263347" cy="263347"/>
-          </a:xfrm>
-          <a:prstGeom prst="rect">
-            <a:avLst/>
-          </a:prstGeom>
-        </p:spPr>
-      </p:pic>
-      <p:sp>
-        <p:nvSpPr>
-          <p:cNvPr id="9" name="Text 6"/>
-          <p:cNvSpPr/>
-          <p:nvPr/>
-        </p:nvSpPr>
-        <p:spPr>
-          <a:xfrm>
-            <a:off x="1572768" y="1755648"/>
-            <a:ext cx="9814255" cy="749808"/>
-          </a:xfrm>
-          <a:prstGeom prst="rect">
-            <a:avLst/>
-          </a:prstGeom>
-          <a:noFill/>
-          <a:ln/>
-        </p:spPr>
-        <p:txBody>
-          <a:bodyPr wrap="square" lIns="0" tIns="0" rIns="0" bIns="0" rtlCol="0" anchor="ctr"/>
-          <a:lstStyle/>
-          <a:p>
-            <a:pPr marL="0" indent="0" algn="l">
-              <a:lnSpc>
-                <a:spcPct val="102000"/>
-              </a:lnSpc>
-              <a:buNone/>
-            </a:pPr>
-            <a:r>
-              <a:rPr lang="en-US" sz="1250" b="1" dirty="0">
-                <a:solidFill>
-                  <a:srgbClr val="FFFFFF"/>
-                </a:solidFill>
-                <a:latin typeface="Calibri" pitchFamily="34" charset="0"/>
-                <a:ea typeface="Calibri" pitchFamily="34" charset="-122"/>
-                <a:cs typeface="Calibri" pitchFamily="34" charset="-120"/>
-              </a:rPr>
-              <a:t>LLM as a supplementary tier — only for the ~10% the engine leaves unresolved.  </a:t>
-            </a:r>
-            <a:r>
-              <a:rPr lang="en-US" sz="1250" dirty="0">
-                <a:solidFill>
-                  <a:srgbClr val="EAD9E4"/>
-                </a:solidFill>
-                <a:latin typeface="Calibri" pitchFamily="34" charset="0"/>
-                <a:ea typeface="Calibri" pitchFamily="34" charset="-122"/>
-                <a:cs typeface="Calibri" pitchFamily="34" charset="-120"/>
-              </a:rPr>
-              <a:t>Complex multi-domain forms (EXACATE, INFSS) where disambiguation needs protocol context. The resolution core stays unchanged; the LLM handles only what specification matching cannot.</a:t>
-            </a:r>
-            <a:endParaRPr lang="en-US" sz="1250" dirty="0"/>
-          </a:p>
-        </p:txBody>
-      </p:sp>
-      <p:sp>
-        <p:nvSpPr>
-          <p:cNvPr id="10" name="Shape 7"/>
-          <p:cNvSpPr/>
-          <p:nvPr/>
-        </p:nvSpPr>
-        <p:spPr>
-          <a:xfrm>
-            <a:off x="548640" y="2889504"/>
-            <a:ext cx="3657600" cy="2788920"/>
-          </a:xfrm>
-          <a:prstGeom prst="roundRect">
-            <a:avLst>
-              <a:gd name="adj" fmla="val 3934"/>
-            </a:avLst>
-          </a:prstGeom>
-          <a:solidFill>
-            <a:srgbClr val="4D0030"/>
-          </a:solidFill>
-          <a:ln/>
-          <a:effectLst>
-            <a:outerShdw blurRad="88900" dist="38100" dir="5400000" algn="bl" rotWithShape="0">
-              <a:srgbClr val="9A8895">
-                <a:alpha val="22000"/>
-              </a:srgbClr>
-            </a:outerShdw>
-          </a:effectLst>
-        </p:spPr>
-        <p:txBody>
-          <a:bodyPr/>
-          <a:lstStyle/>
-          <a:p>
-            <a:endParaRPr lang="en-IN"/>
-          </a:p>
-        </p:txBody>
-      </p:sp>
-      <p:sp>
-        <p:nvSpPr>
-          <p:cNvPr id="11" name="Shape 8"/>
-          <p:cNvSpPr/>
-          <p:nvPr/>
-        </p:nvSpPr>
-        <p:spPr>
-          <a:xfrm>
-            <a:off x="822960" y="3145536"/>
-            <a:ext cx="548640" cy="548640"/>
-          </a:xfrm>
-          <a:prstGeom prst="ellipse">
-            <a:avLst/>
-          </a:prstGeom>
-          <a:solidFill>
-            <a:srgbClr val="D0006F"/>
-          </a:solidFill>
-          <a:ln/>
-        </p:spPr>
-        <p:txBody>
-          <a:bodyPr/>
-          <a:lstStyle/>
-          <a:p>
-            <a:endParaRPr lang="en-IN"/>
-          </a:p>
-        </p:txBody>
-      </p:sp>
-      <p:pic>
-        <p:nvPicPr>
-          <p:cNvPr id="12" name="Image 1" descr="/tmp/build/icons/puzzle_white.png"/>
-          <p:cNvPicPr>
-            <a:picLocks noChangeAspect="1"/>
-          </p:cNvPicPr>
-          <p:nvPr/>
-        </p:nvPicPr>
-        <p:blipFill>
-          <a:blip r:embed="rId4"/>
-          <a:stretch>
-            <a:fillRect/>
-          </a:stretch>
-        </p:blipFill>
-        <p:spPr>
-          <a:xfrm>
-            <a:off x="965606" y="3288182"/>
-            <a:ext cx="263347" cy="263347"/>
-          </a:xfrm>
-          <a:prstGeom prst="rect">
-            <a:avLst/>
-          </a:prstGeom>
-        </p:spPr>
-      </p:pic>
-      <p:sp>
-        <p:nvSpPr>
-          <p:cNvPr id="13" name="Text 9"/>
-          <p:cNvSpPr/>
-          <p:nvPr/>
-        </p:nvSpPr>
-        <p:spPr>
-          <a:xfrm>
-            <a:off x="1499616" y="3127248"/>
-            <a:ext cx="2468880" cy="548640"/>
-          </a:xfrm>
-          <a:prstGeom prst="rect">
-            <a:avLst/>
-          </a:prstGeom>
-          <a:noFill/>
-          <a:ln/>
-        </p:spPr>
-        <p:txBody>
-          <a:bodyPr wrap="square" lIns="0" tIns="0" rIns="0" bIns="0" rtlCol="0" anchor="ctr"/>
-          <a:lstStyle/>
-          <a:p>
-            <a:pPr marL="0" indent="0" algn="l">
-              <a:buNone/>
-            </a:pPr>
-            <a:r>
-              <a:rPr lang="en-US" sz="1500" b="1" dirty="0">
-                <a:solidFill>
-                  <a:srgbClr val="FFFFFF"/>
-                </a:solidFill>
-                <a:latin typeface="Century Schoolbook" pitchFamily="34" charset="0"/>
-                <a:ea typeface="Century Schoolbook" pitchFamily="34" charset="-122"/>
-                <a:cs typeface="Century Schoolbook" pitchFamily="34" charset="-120"/>
-              </a:rPr>
-              <a:t>Planned use cases</a:t>
-            </a:r>
-            <a:endParaRPr lang="en-US" sz="1500" dirty="0"/>
-          </a:p>
-        </p:txBody>
-      </p:sp>
-      <p:sp>
-        <p:nvSpPr>
-          <p:cNvPr id="14" name="Text 10"/>
-          <p:cNvSpPr/>
-          <p:nvPr/>
-        </p:nvSpPr>
-        <p:spPr>
-          <a:xfrm>
-            <a:off x="859536" y="3767328"/>
-            <a:ext cx="3072384" cy="1783080"/>
-          </a:xfrm>
-          <a:prstGeom prst="rect">
-            <a:avLst/>
-          </a:prstGeom>
-          <a:noFill/>
-          <a:ln/>
-        </p:spPr>
-        <p:txBody>
-          <a:bodyPr wrap="square" lIns="0" tIns="0" rIns="0" bIns="0" rtlCol="0" anchor="t"/>
-          <a:lstStyle/>
-          <a:p>
-            <a:pPr marL="342900" indent="-342900" algn="l">
-              <a:lnSpc>
-                <a:spcPct val="100000"/>
-              </a:lnSpc>
-              <a:spcAft>
-                <a:spcPts val="1000"/>
-              </a:spcAft>
-              <a:buSzPct val="100000"/>
-              <a:buChar char="•"/>
-            </a:pPr>
-            <a:r>
-              <a:rPr lang="en-US" sz="1160" dirty="0">
-                <a:solidFill>
-                  <a:srgbClr val="EAD9E4"/>
-                </a:solidFill>
-                <a:latin typeface="Calibri" pitchFamily="34" charset="0"/>
-                <a:ea typeface="Calibri" pitchFamily="34" charset="-122"/>
-                <a:cs typeface="Calibri" pitchFamily="34" charset="-120"/>
-              </a:rPr>
-              <a:t>Disambiguate fields spanning domains (e.g. "Shortness of Breath" → CE or FA?)</a:t>
-            </a:r>
-            <a:endParaRPr lang="en-US" sz="1160" dirty="0"/>
-          </a:p>
-          <a:p>
-            <a:pPr marL="342900" indent="-342900" algn="l">
-              <a:lnSpc>
-                <a:spcPct val="100000"/>
-              </a:lnSpc>
-              <a:spcAft>
-                <a:spcPts val="1000"/>
-              </a:spcAft>
-              <a:buSzPct val="100000"/>
-              <a:buChar char="•"/>
-            </a:pPr>
-            <a:r>
-              <a:rPr lang="en-US" sz="1160" dirty="0">
-                <a:solidFill>
-                  <a:srgbClr val="EAD9E4"/>
-                </a:solidFill>
-                <a:latin typeface="Calibri" pitchFamily="34" charset="0"/>
-                <a:ea typeface="Calibri" pitchFamily="34" charset="-122"/>
-                <a:cs typeface="Calibri" pitchFamily="34" charset="-120"/>
-              </a:rPr>
-              <a:t>MedDRA dictionary-field resolution via contextual inference</a:t>
-            </a:r>
-            <a:endParaRPr lang="en-US" sz="1160" dirty="0"/>
-          </a:p>
-          <a:p>
-            <a:pPr marL="342900" indent="-342900" algn="l">
-              <a:lnSpc>
-                <a:spcPct val="100000"/>
-              </a:lnSpc>
-              <a:buSzPct val="100000"/>
-              <a:buChar char="•"/>
-            </a:pPr>
-            <a:r>
-              <a:rPr lang="en-US" sz="1160" dirty="0">
-                <a:solidFill>
-                  <a:srgbClr val="EAD9E4"/>
-                </a:solidFill>
-                <a:latin typeface="Calibri" pitchFamily="34" charset="0"/>
-                <a:ea typeface="Calibri" pitchFamily="34" charset="-122"/>
-                <a:cs typeface="Calibri" pitchFamily="34" charset="-120"/>
-              </a:rPr>
-              <a:t>Quality check — LLM as a second opinion on low-confidence Tier 2 matches</a:t>
-            </a:r>
-            <a:endParaRPr lang="en-US" sz="1160" dirty="0"/>
-          </a:p>
-        </p:txBody>
-      </p:sp>
-      <p:sp>
-        <p:nvSpPr>
-          <p:cNvPr id="15" name="Shape 11"/>
-          <p:cNvSpPr/>
-          <p:nvPr/>
-        </p:nvSpPr>
-        <p:spPr>
-          <a:xfrm>
-            <a:off x="4572000" y="2889504"/>
-            <a:ext cx="3429000" cy="2788920"/>
-          </a:xfrm>
-          <a:prstGeom prst="roundRect">
-            <a:avLst>
-              <a:gd name="adj" fmla="val 3934"/>
-            </a:avLst>
-          </a:prstGeom>
-          <a:solidFill>
-            <a:srgbClr val="4D0030"/>
-          </a:solidFill>
-          <a:ln/>
-          <a:effectLst>
-            <a:outerShdw blurRad="88900" dist="38100" dir="5400000" algn="bl" rotWithShape="0">
-              <a:srgbClr val="9A8895">
-                <a:alpha val="22000"/>
-              </a:srgbClr>
-            </a:outerShdw>
-          </a:effectLst>
-        </p:spPr>
-        <p:txBody>
-          <a:bodyPr/>
-          <a:lstStyle/>
-          <a:p>
-            <a:endParaRPr lang="en-IN"/>
-          </a:p>
-        </p:txBody>
-      </p:sp>
-      <p:sp>
-        <p:nvSpPr>
-          <p:cNvPr id="16" name="Shape 12"/>
-          <p:cNvSpPr/>
-          <p:nvPr/>
-        </p:nvSpPr>
-        <p:spPr>
-          <a:xfrm>
-            <a:off x="4846320" y="3145536"/>
-            <a:ext cx="548640" cy="548640"/>
-          </a:xfrm>
-          <a:prstGeom prst="ellipse">
-            <a:avLst/>
-          </a:prstGeom>
-          <a:solidFill>
-            <a:srgbClr val="D0006F"/>
-          </a:solidFill>
-          <a:ln/>
-        </p:spPr>
-        <p:txBody>
-          <a:bodyPr/>
-          <a:lstStyle/>
-          <a:p>
-            <a:endParaRPr lang="en-IN"/>
-          </a:p>
-        </p:txBody>
-      </p:sp>
-      <p:pic>
-        <p:nvPicPr>
-          <p:cNvPr id="17" name="Image 2" descr="/tmp/build/icons/road_white.png"/>
-          <p:cNvPicPr>
-            <a:picLocks noChangeAspect="1"/>
-          </p:cNvPicPr>
-          <p:nvPr/>
-        </p:nvPicPr>
-        <p:blipFill>
-          <a:blip r:embed="rId5"/>
-          <a:stretch>
-            <a:fillRect/>
-          </a:stretch>
-        </p:blipFill>
-        <p:spPr>
-          <a:xfrm>
-            <a:off x="4988966" y="3288182"/>
-            <a:ext cx="263347" cy="263347"/>
-          </a:xfrm>
-          <a:prstGeom prst="rect">
-            <a:avLst/>
-          </a:prstGeom>
-        </p:spPr>
-      </p:pic>
-      <p:sp>
-        <p:nvSpPr>
-          <p:cNvPr id="18" name="Text 13"/>
-          <p:cNvSpPr/>
-          <p:nvPr/>
-        </p:nvSpPr>
-        <p:spPr>
-          <a:xfrm>
-            <a:off x="5522976" y="3127248"/>
-            <a:ext cx="2240280" cy="548640"/>
-          </a:xfrm>
-          <a:prstGeom prst="rect">
-            <a:avLst/>
-          </a:prstGeom>
-          <a:noFill/>
-          <a:ln/>
-        </p:spPr>
-        <p:txBody>
-          <a:bodyPr wrap="square" lIns="0" tIns="0" rIns="0" bIns="0" rtlCol="0" anchor="ctr"/>
-          <a:lstStyle/>
-          <a:p>
-            <a:pPr marL="0" indent="0" algn="l">
-              <a:buNone/>
-            </a:pPr>
-            <a:r>
-              <a:rPr lang="en-US" sz="1500" b="1" dirty="0">
-                <a:solidFill>
-                  <a:srgbClr val="FFFFFF"/>
-                </a:solidFill>
-                <a:latin typeface="Century Schoolbook" pitchFamily="34" charset="0"/>
-                <a:ea typeface="Century Schoolbook" pitchFamily="34" charset="-122"/>
-                <a:cs typeface="Century Schoolbook" pitchFamily="34" charset="-120"/>
-              </a:rPr>
-              <a:t>Broader roadmap</a:t>
-            </a:r>
-            <a:endParaRPr lang="en-US" sz="1500" dirty="0"/>
-          </a:p>
-        </p:txBody>
-      </p:sp>
-      <p:sp>
-        <p:nvSpPr>
-          <p:cNvPr id="19" name="Text 14"/>
-          <p:cNvSpPr/>
-          <p:nvPr/>
-        </p:nvSpPr>
-        <p:spPr>
-          <a:xfrm>
-            <a:off x="4882896" y="3767328"/>
-            <a:ext cx="2843784" cy="1783080"/>
-          </a:xfrm>
-          <a:prstGeom prst="rect">
-            <a:avLst/>
-          </a:prstGeom>
-          <a:noFill/>
-          <a:ln/>
-        </p:spPr>
-        <p:txBody>
-          <a:bodyPr wrap="square" lIns="0" tIns="0" rIns="0" bIns="0" rtlCol="0" anchor="t"/>
-          <a:lstStyle/>
-          <a:p>
-            <a:pPr marL="342900" indent="-342900" algn="l">
-              <a:lnSpc>
-                <a:spcPct val="100000"/>
-              </a:lnSpc>
-              <a:spcAft>
-                <a:spcPts val="1000"/>
-              </a:spcAft>
-              <a:buSzPct val="100000"/>
-              <a:buChar char="•"/>
-            </a:pPr>
-            <a:r>
-              <a:rPr lang="en-US" sz="1160" dirty="0">
-                <a:solidFill>
-                  <a:srgbClr val="EAD9E4"/>
-                </a:solidFill>
-                <a:latin typeface="Calibri" pitchFamily="34" charset="0"/>
-                <a:ea typeface="Calibri" pitchFamily="34" charset="-122"/>
-                <a:cs typeface="Calibri" pitchFamily="34" charset="-120"/>
-              </a:rPr>
-              <a:t>Multi-study pattern learning — the knowledge base grows as more studies run through the tool</a:t>
-            </a:r>
-            <a:endParaRPr lang="en-US" sz="1160" dirty="0"/>
-          </a:p>
-          <a:p>
-            <a:pPr marL="342900" indent="-342900" algn="l">
-              <a:lnSpc>
-                <a:spcPct val="100000"/>
-              </a:lnSpc>
-              <a:spcAft>
-                <a:spcPts val="1000"/>
-              </a:spcAft>
-              <a:buSzPct val="100000"/>
-              <a:buChar char="•"/>
-            </a:pPr>
-            <a:r>
-              <a:rPr lang="en-US" sz="1160" dirty="0">
-                <a:solidFill>
-                  <a:srgbClr val="EAD9E4"/>
-                </a:solidFill>
-                <a:latin typeface="Calibri" pitchFamily="34" charset="0"/>
-                <a:ea typeface="Calibri" pitchFamily="34" charset="-122"/>
-                <a:cs typeface="Calibri" pitchFamily="34" charset="-120"/>
-              </a:rPr>
-              <a:t>Direct integration with EDC system exports for streamlined input</a:t>
-            </a:r>
-            <a:endParaRPr lang="en-US" sz="1160" dirty="0"/>
-          </a:p>
-          <a:p>
-            <a:pPr marL="342900" indent="-342900" algn="l">
-              <a:lnSpc>
-                <a:spcPct val="100000"/>
-              </a:lnSpc>
-              <a:buSzPct val="100000"/>
-              <a:buChar char="•"/>
-            </a:pPr>
-            <a:r>
-              <a:rPr lang="en-US" sz="1160" dirty="0">
-                <a:solidFill>
-                  <a:srgbClr val="EAD9E4"/>
-                </a:solidFill>
-                <a:latin typeface="Calibri" pitchFamily="34" charset="0"/>
-                <a:ea typeface="Calibri" pitchFamily="34" charset="-122"/>
-                <a:cs typeface="Calibri" pitchFamily="34" charset="-120"/>
-              </a:rPr>
-              <a:t>Architecture ready to connect to an AZ-approved LLM API endpoint when access is available</a:t>
-            </a:r>
-            <a:endParaRPr lang="en-US" sz="1160" dirty="0"/>
-          </a:p>
-        </p:txBody>
-      </p:sp>
-      <p:sp>
-        <p:nvSpPr>
-          <p:cNvPr id="20" name="Shape 15"/>
-          <p:cNvSpPr/>
-          <p:nvPr/>
-        </p:nvSpPr>
-        <p:spPr>
-          <a:xfrm>
-            <a:off x="8275320" y="2889504"/>
-            <a:ext cx="3367735" cy="2788920"/>
-          </a:xfrm>
-          <a:prstGeom prst="roundRect">
-            <a:avLst>
-              <a:gd name="adj" fmla="val 3934"/>
-            </a:avLst>
-          </a:prstGeom>
-          <a:solidFill>
-            <a:srgbClr val="F0AB00"/>
-          </a:solidFill>
-          <a:ln/>
-          <a:effectLst>
-            <a:outerShdw blurRad="88900" dist="38100" dir="5400000" algn="bl" rotWithShape="0">
-              <a:srgbClr val="9A8895">
-                <a:alpha val="22000"/>
-              </a:srgbClr>
-            </a:outerShdw>
-          </a:effectLst>
-        </p:spPr>
-        <p:txBody>
-          <a:bodyPr/>
-          <a:lstStyle/>
-          <a:p>
-            <a:endParaRPr lang="en-IN"/>
-          </a:p>
-        </p:txBody>
-      </p:sp>
-      <p:sp>
-        <p:nvSpPr>
-          <p:cNvPr id="21" name="Text 16"/>
-          <p:cNvSpPr/>
-          <p:nvPr/>
-        </p:nvSpPr>
-        <p:spPr>
-          <a:xfrm>
-            <a:off x="8549640" y="3200400"/>
-            <a:ext cx="2819095" cy="329184"/>
-          </a:xfrm>
-          <a:prstGeom prst="rect">
-            <a:avLst/>
-          </a:prstGeom>
-          <a:noFill/>
-          <a:ln/>
-        </p:spPr>
-        <p:txBody>
-          <a:bodyPr wrap="square" lIns="0" tIns="0" rIns="0" bIns="0" rtlCol="0" anchor="ctr"/>
-          <a:lstStyle/>
-          <a:p>
-            <a:pPr marL="0" indent="0" algn="l">
-              <a:buNone/>
-            </a:pPr>
-            <a:r>
-              <a:rPr lang="en-US" sz="1100" b="1" kern="0" spc="150" dirty="0">
-                <a:solidFill>
-                  <a:srgbClr val="6B4E00"/>
-                </a:solidFill>
-                <a:latin typeface="Calibri" pitchFamily="34" charset="0"/>
-                <a:ea typeface="Calibri" pitchFamily="34" charset="-122"/>
-                <a:cs typeface="Calibri" pitchFamily="34" charset="-120"/>
-              </a:rPr>
-              <a:t>PROJECTED RESOLUTION</a:t>
-            </a:r>
-            <a:endParaRPr lang="en-US" sz="1100" dirty="0"/>
-          </a:p>
-        </p:txBody>
-      </p:sp>
-      <p:sp>
-        <p:nvSpPr>
-          <p:cNvPr id="22" name="Text 17"/>
-          <p:cNvSpPr/>
-          <p:nvPr/>
-        </p:nvSpPr>
-        <p:spPr>
-          <a:xfrm>
-            <a:off x="8549640" y="3566160"/>
-            <a:ext cx="2819095" cy="914400"/>
-          </a:xfrm>
-          <a:prstGeom prst="rect">
-            <a:avLst/>
-          </a:prstGeom>
-          <a:noFill/>
-          <a:ln/>
-        </p:spPr>
-        <p:txBody>
-          <a:bodyPr wrap="square" lIns="0" tIns="0" rIns="0" bIns="0" rtlCol="0" anchor="ctr"/>
-          <a:lstStyle/>
-          <a:p>
-            <a:pPr marL="0" indent="0" algn="l">
-              <a:buNone/>
-            </a:pPr>
-            <a:r>
-              <a:rPr lang="en-US" sz="4600" b="1" dirty="0">
-                <a:solidFill>
-                  <a:srgbClr val="5A4200"/>
-                </a:solidFill>
-                <a:latin typeface="Century Schoolbook" pitchFamily="34" charset="0"/>
-                <a:ea typeface="Century Schoolbook" pitchFamily="34" charset="-122"/>
-                <a:cs typeface="Century Schoolbook" pitchFamily="34" charset="-120"/>
-              </a:rPr>
-              <a:t>97–99%</a:t>
-            </a:r>
-            <a:endParaRPr lang="en-US" sz="4600" dirty="0"/>
-          </a:p>
-        </p:txBody>
-      </p:sp>
-      <p:sp>
-        <p:nvSpPr>
-          <p:cNvPr id="23" name="Text 18"/>
-          <p:cNvSpPr/>
-          <p:nvPr/>
-        </p:nvSpPr>
-        <p:spPr>
-          <a:xfrm>
-            <a:off x="8549640" y="4517136"/>
-            <a:ext cx="2819095" cy="1005840"/>
-          </a:xfrm>
-          <a:prstGeom prst="rect">
-            <a:avLst/>
-          </a:prstGeom>
-          <a:noFill/>
-          <a:ln/>
-        </p:spPr>
-        <p:txBody>
-          <a:bodyPr wrap="square" lIns="0" tIns="0" rIns="0" bIns="0" rtlCol="0" anchor="t"/>
-          <a:lstStyle/>
-          <a:p>
-            <a:pPr marL="0" indent="0" algn="l">
-              <a:lnSpc>
-                <a:spcPct val="104000"/>
-              </a:lnSpc>
-              <a:buNone/>
-            </a:pPr>
-            <a:r>
-              <a:rPr lang="en-US" sz="1200" b="1" dirty="0">
-                <a:solidFill>
-                  <a:srgbClr val="5A4200"/>
-                </a:solidFill>
-                <a:latin typeface="Calibri" pitchFamily="34" charset="0"/>
-                <a:ea typeface="Calibri" pitchFamily="34" charset="-122"/>
-                <a:cs typeface="Calibri" pitchFamily="34" charset="-120"/>
-              </a:rPr>
-              <a:t>with the LLM handling the remaining edge cases — built to CDISC aCRF conventions, human-in-the-loop throughout.</a:t>
-            </a:r>
-            <a:endParaRPr lang="en-US" sz="1200" dirty="0"/>
-          </a:p>
-        </p:txBody>
-      </p:sp>
-      <p:sp>
-        <p:nvSpPr>
-          <p:cNvPr id="24" name="Text 19"/>
-          <p:cNvSpPr/>
-          <p:nvPr/>
-        </p:nvSpPr>
-        <p:spPr>
-          <a:xfrm>
-            <a:off x="548640" y="6382512"/>
-            <a:ext cx="7315200" cy="310896"/>
-          </a:xfrm>
-          <a:prstGeom prst="rect">
-            <a:avLst/>
-          </a:prstGeom>
-          <a:noFill/>
-          <a:ln/>
-        </p:spPr>
-        <p:txBody>
-          <a:bodyPr wrap="square" lIns="0" tIns="0" rIns="0" bIns="0" rtlCol="0" anchor="ctr"/>
-          <a:lstStyle/>
-          <a:p>
-            <a:pPr marL="0" indent="0" algn="l">
-              <a:buNone/>
-            </a:pPr>
-            <a:r>
-              <a:rPr lang="en-US" sz="1400" b="1" i="1" dirty="0">
-                <a:solidFill>
-                  <a:srgbClr val="68D2DF"/>
-                </a:solidFill>
-                <a:latin typeface="Century Schoolbook" pitchFamily="34" charset="0"/>
-                <a:ea typeface="Century Schoolbook" pitchFamily="34" charset="-122"/>
-                <a:cs typeface="Century Schoolbook" pitchFamily="34" charset="-120"/>
-              </a:rPr>
-              <a:t>Thank you — questions welcome</a:t>
-            </a:r>
-            <a:endParaRPr lang="en-US" sz="1400" dirty="0"/>
           </a:p>
         </p:txBody>
       </p:sp>

</xml_diff>